<commit_message>
Rebalance gallery: per-topic best design + translated pair, 4 light / 4 dark covers
- Each topic now uses one chosen design; the other language is a faithful translation (same design, translated text, numbers unchanged)
- Rebalanced covers to 4 light (transformer, nl-job reskinned, kids, chengdu) + 4 dark (nvidia, solo, standup, mj)
- Hover preview now cycles first 5 pages (was 3)
- Regenerated all renders, template.pptx, preview composites, decks.js page counts

Co-Authored-By: Claude Fable 5 <noreply@anthropic.com>
</commit_message>
<xml_diff>
--- a/templates/decks/en/nl-job-market-2026/template.pptx
+++ b/templates/decks/en/nl-job-market-2026/template.pptx
@@ -4070,7 +4070,7 @@
             <a:avLst/>
           </a:prstGeom>
           <a:solidFill>
-            <a:srgbClr val="16223A"/>
+            <a:srgbClr val="F4EFE6"/>
           </a:solidFill>
           <a:ln>
             <a:noFill/>
@@ -4114,7 +4114,7 @@
             <a:avLst/>
           </a:prstGeom>
           <a:solidFill>
-            <a:srgbClr val="0F1A2E"/>
+            <a:srgbClr val="EAE1D2"/>
           </a:solidFill>
           <a:ln>
             <a:noFill/>
@@ -4224,7 +4224,7 @@
             <a:r>
               <a:rPr sz="1100" b="1" i="0" spc="150">
                 <a:solidFill>
-                  <a:srgbClr val="2E8A8C"/>
+                  <a:srgbClr val="0E5C63"/>
                 </a:solidFill>
                 <a:latin typeface="Courier New"/>
               </a:rPr>
@@ -4270,7 +4270,7 @@
             <a:r>
               <a:rPr sz="5200" b="1" i="0">
                 <a:solidFill>
-                  <a:srgbClr val="F1EBDD"/>
+                  <a:srgbClr val="20242A"/>
                 </a:solidFill>
                 <a:latin typeface="Georgia"/>
               </a:rPr>
@@ -4292,7 +4292,7 @@
             <a:r>
               <a:rPr sz="5200" b="1" i="0">
                 <a:solidFill>
-                  <a:srgbClr val="F1EBDD"/>
+                  <a:srgbClr val="20242A"/>
                 </a:solidFill>
                 <a:latin typeface="Georgia"/>
               </a:rPr>
@@ -4391,7 +4391,7 @@
             <a:r>
               <a:rPr sz="1650" b="0" i="0">
                 <a:solidFill>
-                  <a:srgbClr val="C9D2DE"/>
+                  <a:srgbClr val="4A4E56"/>
                 </a:solidFill>
                 <a:latin typeface="Helvetica Neue"/>
               </a:rPr>
@@ -4437,7 +4437,7 @@
             <a:r>
               <a:rPr sz="950" b="1" i="0" spc="150">
                 <a:solidFill>
-                  <a:srgbClr val="9BA6B4"/>
+                  <a:srgbClr val="8A8478"/>
                 </a:solidFill>
                 <a:latin typeface="Courier New"/>
               </a:rPr>
@@ -6475,10 +6475,12 @@
             </a:avLst>
           </a:prstGeom>
           <a:solidFill>
-            <a:srgbClr val="16223A"/>
+            <a:srgbClr val="ECE4D6"/>
           </a:solidFill>
-          <a:ln>
-            <a:noFill/>
+          <a:ln w="12700">
+            <a:solidFill>
+              <a:srgbClr val="DED7C8"/>
+            </a:solidFill>
           </a:ln>
           <a:effectLst/>
         </p:spPr>
@@ -6550,7 +6552,7 @@
             <a:r>
               <a:rPr sz="1300" b="0" i="0">
                 <a:solidFill>
-                  <a:srgbClr val="C9D2DE"/>
+                  <a:srgbClr val="4A4E56"/>
                 </a:solidFill>
                 <a:latin typeface="Helvetica Neue"/>
               </a:rPr>
@@ -6596,7 +6598,7 @@
             <a:r>
               <a:rPr sz="1050" b="0" i="0">
                 <a:solidFill>
-                  <a:srgbClr val="9BA6B4"/>
+                  <a:srgbClr val="8A8478"/>
                 </a:solidFill>
                 <a:latin typeface="Helvetica Neue"/>
               </a:rPr>
@@ -7057,7 +7059,7 @@
             <a:avLst/>
           </a:prstGeom>
           <a:solidFill>
-            <a:srgbClr val="16223A"/>
+            <a:srgbClr val="F4EFE6"/>
           </a:solidFill>
           <a:ln>
             <a:noFill/>
@@ -7123,7 +7125,7 @@
             <a:r>
               <a:rPr sz="1100" b="1" i="0" spc="150">
                 <a:solidFill>
-                  <a:srgbClr val="2E8A8C"/>
+                  <a:srgbClr val="0E5C63"/>
                 </a:solidFill>
                 <a:latin typeface="Courier New"/>
               </a:rPr>
@@ -7213,7 +7215,7 @@
             <a:r>
               <a:rPr sz="3000" b="1" i="0">
                 <a:solidFill>
-                  <a:srgbClr val="F1EBDD"/>
+                  <a:srgbClr val="20242A"/>
                 </a:solidFill>
                 <a:latin typeface="Georgia"/>
               </a:rPr>
@@ -7239,10 +7241,12 @@
             </a:avLst>
           </a:prstGeom>
           <a:solidFill>
-            <a:srgbClr val="0F1A2E"/>
+            <a:srgbClr val="ECE4D6"/>
           </a:solidFill>
-          <a:ln>
-            <a:noFill/>
+          <a:ln w="12700">
+            <a:solidFill>
+              <a:srgbClr val="DED7C8"/>
+            </a:solidFill>
           </a:ln>
           <a:effectLst/>
         </p:spPr>
@@ -7285,7 +7289,7 @@
             </a:avLst>
           </a:prstGeom>
           <a:solidFill>
-            <a:srgbClr val="24314C"/>
+            <a:srgbClr val="DDE8E9"/>
           </a:solidFill>
           <a:ln>
             <a:noFill/>
@@ -7421,7 +7425,7 @@
             <a:r>
               <a:rPr sz="1150" b="0" i="0">
                 <a:solidFill>
-                  <a:srgbClr val="C9D2DE"/>
+                  <a:srgbClr val="4A4E56"/>
                 </a:solidFill>
                 <a:latin typeface="Helvetica Neue"/>
               </a:rPr>
@@ -7447,10 +7451,12 @@
             </a:avLst>
           </a:prstGeom>
           <a:solidFill>
-            <a:srgbClr val="0F1A2E"/>
+            <a:srgbClr val="ECE4D6"/>
           </a:solidFill>
-          <a:ln>
-            <a:noFill/>
+          <a:ln w="12700">
+            <a:solidFill>
+              <a:srgbClr val="DED7C8"/>
+            </a:solidFill>
           </a:ln>
           <a:effectLst/>
         </p:spPr>
@@ -7493,7 +7499,7 @@
             </a:avLst>
           </a:prstGeom>
           <a:solidFill>
-            <a:srgbClr val="24314C"/>
+            <a:srgbClr val="E1EEEE"/>
           </a:solidFill>
           <a:ln>
             <a:noFill/>
@@ -7629,7 +7635,7 @@
             <a:r>
               <a:rPr sz="1150" b="0" i="0">
                 <a:solidFill>
-                  <a:srgbClr val="C9D2DE"/>
+                  <a:srgbClr val="4A4E56"/>
                 </a:solidFill>
                 <a:latin typeface="Helvetica Neue"/>
               </a:rPr>
@@ -7655,10 +7661,12 @@
             </a:avLst>
           </a:prstGeom>
           <a:solidFill>
-            <a:srgbClr val="0F1A2E"/>
+            <a:srgbClr val="ECE4D6"/>
           </a:solidFill>
-          <a:ln>
-            <a:noFill/>
+          <a:ln w="12700">
+            <a:solidFill>
+              <a:srgbClr val="DED7C8"/>
+            </a:solidFill>
           </a:ln>
           <a:effectLst/>
         </p:spPr>
@@ -7701,7 +7709,7 @@
             </a:avLst>
           </a:prstGeom>
           <a:solidFill>
-            <a:srgbClr val="24314C"/>
+            <a:srgbClr val="F9E7E1"/>
           </a:solidFill>
           <a:ln>
             <a:noFill/>
@@ -7837,7 +7845,7 @@
             <a:r>
               <a:rPr sz="1150" b="0" i="0">
                 <a:solidFill>
-                  <a:srgbClr val="C9D2DE"/>
+                  <a:srgbClr val="4A4E56"/>
                 </a:solidFill>
                 <a:latin typeface="Helvetica Neue"/>
               </a:rPr>
@@ -7883,7 +7891,7 @@
             <a:r>
               <a:rPr sz="800" b="1" i="0">
                 <a:solidFill>
-                  <a:srgbClr val="2E8A8C"/>
+                  <a:srgbClr val="D8542A"/>
                 </a:solidFill>
                 <a:latin typeface="Courier New"/>
               </a:rPr>
@@ -7892,7 +7900,7 @@
             <a:r>
               <a:rPr sz="850" b="0" i="0">
                 <a:solidFill>
-                  <a:srgbClr val="9BA6B4"/>
+                  <a:srgbClr val="8A8478"/>
                 </a:solidFill>
                 <a:latin typeface="Courier New"/>
               </a:rPr>
@@ -7938,7 +7946,7 @@
             <a:r>
               <a:rPr sz="800" b="0" i="0">
                 <a:solidFill>
-                  <a:srgbClr val="9BA6B4"/>
+                  <a:srgbClr val="8A8478"/>
                 </a:solidFill>
                 <a:latin typeface="Courier New"/>
               </a:rPr>
@@ -7984,7 +7992,7 @@
             <a:r>
               <a:rPr sz="900" b="1" i="0">
                 <a:solidFill>
-                  <a:srgbClr val="9BA6B4"/>
+                  <a:srgbClr val="8A8478"/>
                 </a:solidFill>
                 <a:latin typeface="Courier New"/>
               </a:rPr>
@@ -8026,7 +8034,7 @@
             <a:avLst/>
           </a:prstGeom>
           <a:solidFill>
-            <a:srgbClr val="16223A"/>
+            <a:srgbClr val="F4EFE6"/>
           </a:solidFill>
           <a:ln>
             <a:noFill/>
@@ -8092,7 +8100,7 @@
             <a:r>
               <a:rPr sz="1100" b="1" i="0" spc="150">
                 <a:solidFill>
-                  <a:srgbClr val="2E8A8C"/>
+                  <a:srgbClr val="0E5C63"/>
                 </a:solidFill>
                 <a:latin typeface="Courier New"/>
               </a:rPr>
@@ -8182,7 +8190,7 @@
             <a:r>
               <a:rPr sz="2900" b="1" i="0">
                 <a:solidFill>
-                  <a:srgbClr val="F1EBDD"/>
+                  <a:srgbClr val="20242A"/>
                 </a:solidFill>
                 <a:latin typeface="Georgia"/>
               </a:rPr>
@@ -8274,7 +8282,7 @@
             <a:r>
               <a:rPr sz="1400" b="1" i="0">
                 <a:solidFill>
-                  <a:srgbClr val="F1EBDD"/>
+                  <a:srgbClr val="20242A"/>
                 </a:solidFill>
                 <a:latin typeface="Georgia"/>
               </a:rPr>
@@ -8320,7 +8328,7 @@
             <a:r>
               <a:rPr sz="1150" b="0" i="0">
                 <a:solidFill>
-                  <a:srgbClr val="C9D2DE"/>
+                  <a:srgbClr val="4A4E56"/>
                 </a:solidFill>
                 <a:latin typeface="Helvetica Neue"/>
               </a:rPr>
@@ -8344,7 +8352,7 @@
             <a:avLst/>
           </a:prstGeom>
           <a:solidFill>
-            <a:srgbClr val="2A3852"/>
+            <a:srgbClr val="DED7C8"/>
           </a:solidFill>
           <a:ln>
             <a:noFill/>
@@ -8456,7 +8464,7 @@
             <a:r>
               <a:rPr sz="1400" b="1" i="0">
                 <a:solidFill>
-                  <a:srgbClr val="F1EBDD"/>
+                  <a:srgbClr val="20242A"/>
                 </a:solidFill>
                 <a:latin typeface="Georgia"/>
               </a:rPr>
@@ -8502,7 +8510,7 @@
             <a:r>
               <a:rPr sz="1150" b="0" i="0">
                 <a:solidFill>
-                  <a:srgbClr val="C9D2DE"/>
+                  <a:srgbClr val="4A4E56"/>
                 </a:solidFill>
                 <a:latin typeface="Helvetica Neue"/>
               </a:rPr>
@@ -8526,7 +8534,7 @@
             <a:avLst/>
           </a:prstGeom>
           <a:solidFill>
-            <a:srgbClr val="2A3852"/>
+            <a:srgbClr val="DED7C8"/>
           </a:solidFill>
           <a:ln>
             <a:noFill/>
@@ -8638,7 +8646,7 @@
             <a:r>
               <a:rPr sz="1400" b="1" i="0">
                 <a:solidFill>
-                  <a:srgbClr val="F1EBDD"/>
+                  <a:srgbClr val="20242A"/>
                 </a:solidFill>
                 <a:latin typeface="Georgia"/>
               </a:rPr>
@@ -8684,7 +8692,7 @@
             <a:r>
               <a:rPr sz="1150" b="0" i="0">
                 <a:solidFill>
-                  <a:srgbClr val="C9D2DE"/>
+                  <a:srgbClr val="4A4E56"/>
                 </a:solidFill>
                 <a:latin typeface="Helvetica Neue"/>
               </a:rPr>
@@ -8708,7 +8716,7 @@
             <a:avLst/>
           </a:prstGeom>
           <a:solidFill>
-            <a:srgbClr val="2A3852"/>
+            <a:srgbClr val="DED7C8"/>
           </a:solidFill>
           <a:ln>
             <a:noFill/>
@@ -8820,7 +8828,7 @@
             <a:r>
               <a:rPr sz="1400" b="1" i="0">
                 <a:solidFill>
-                  <a:srgbClr val="F1EBDD"/>
+                  <a:srgbClr val="20242A"/>
                 </a:solidFill>
                 <a:latin typeface="Georgia"/>
               </a:rPr>
@@ -8866,7 +8874,7 @@
             <a:r>
               <a:rPr sz="1150" b="0" i="0">
                 <a:solidFill>
-                  <a:srgbClr val="C9D2DE"/>
+                  <a:srgbClr val="4A4E56"/>
                 </a:solidFill>
                 <a:latin typeface="Helvetica Neue"/>
               </a:rPr>
@@ -8890,7 +8898,7 @@
             <a:avLst/>
           </a:prstGeom>
           <a:solidFill>
-            <a:srgbClr val="2A3852"/>
+            <a:srgbClr val="DED7C8"/>
           </a:solidFill>
           <a:ln>
             <a:noFill/>
@@ -9002,7 +9010,7 @@
             <a:r>
               <a:rPr sz="1400" b="1" i="0">
                 <a:solidFill>
-                  <a:srgbClr val="F1EBDD"/>
+                  <a:srgbClr val="20242A"/>
                 </a:solidFill>
                 <a:latin typeface="Georgia"/>
               </a:rPr>
@@ -9048,7 +9056,7 @@
             <a:r>
               <a:rPr sz="1150" b="0" i="0">
                 <a:solidFill>
-                  <a:srgbClr val="C9D2DE"/>
+                  <a:srgbClr val="4A4E56"/>
                 </a:solidFill>
                 <a:latin typeface="Helvetica Neue"/>
               </a:rPr>
@@ -9094,7 +9102,7 @@
             <a:r>
               <a:rPr sz="800" b="0" i="0">
                 <a:solidFill>
-                  <a:srgbClr val="9BA6B4"/>
+                  <a:srgbClr val="8A8478"/>
                 </a:solidFill>
                 <a:latin typeface="Courier New"/>
               </a:rPr>
@@ -9140,7 +9148,7 @@
             <a:r>
               <a:rPr sz="900" b="1" i="0">
                 <a:solidFill>
-                  <a:srgbClr val="9BA6B4"/>
+                  <a:srgbClr val="8A8478"/>
                 </a:solidFill>
                 <a:latin typeface="Courier New"/>
               </a:rPr>
@@ -12436,7 +12444,7 @@
             </a:avLst>
           </a:prstGeom>
           <a:solidFill>
-            <a:srgbClr val="16223A"/>
+            <a:srgbClr val="FAEAE5"/>
           </a:solidFill>
           <a:ln>
             <a:noFill/>
@@ -12555,7 +12563,7 @@
             <a:r>
               <a:rPr sz="1350" b="0" i="0">
                 <a:solidFill>
-                  <a:srgbClr val="FFFFFF"/>
+                  <a:srgbClr val="20242A"/>
                 </a:solidFill>
                 <a:latin typeface="Helvetica Neue"/>
               </a:rPr>
@@ -13327,10 +13335,12 @@
             </a:avLst>
           </a:prstGeom>
           <a:solidFill>
-            <a:srgbClr val="16223A"/>
+            <a:srgbClr val="ECE4D6"/>
           </a:solidFill>
-          <a:ln>
-            <a:noFill/>
+          <a:ln w="12700">
+            <a:solidFill>
+              <a:srgbClr val="DED7C8"/>
+            </a:solidFill>
           </a:ln>
           <a:effectLst/>
         </p:spPr>
@@ -13393,7 +13403,7 @@
             <a:r>
               <a:rPr sz="1050" b="1" i="0">
                 <a:solidFill>
-                  <a:srgbClr val="2E8A8C"/>
+                  <a:srgbClr val="0E5C63"/>
                 </a:solidFill>
                 <a:latin typeface="Courier New"/>
               </a:rPr>
@@ -13439,7 +13449,7 @@
             <a:r>
               <a:rPr sz="2000" b="1" i="0">
                 <a:solidFill>
-                  <a:srgbClr val="F1EBDD"/>
+                  <a:srgbClr val="20242A"/>
                 </a:solidFill>
                 <a:latin typeface="Georgia"/>
               </a:rPr>
@@ -13531,7 +13541,7 @@
             <a:r>
               <a:rPr sz="1100" b="0" i="0">
                 <a:solidFill>
-                  <a:srgbClr val="C9D2DE"/>
+                  <a:srgbClr val="4A4E56"/>
                 </a:solidFill>
                 <a:latin typeface="Helvetica Neue"/>
               </a:rPr>

</xml_diff>

<commit_message>
transformer/nl-job covers: remove accent hairlines
</commit_message>
<xml_diff>
--- a/templates/decks/en/nl-job-market-2026/template.pptx
+++ b/templates/decks/en/nl-job-market-2026/template.pptx
@@ -4145,51 +4145,7 @@
       </p:sp>
       <p:sp>
         <p:nvSpPr>
-          <p:cNvPr id="4" name="Rectangle 3"/>
-          <p:cNvSpPr/>
-          <p:nvPr/>
-        </p:nvSpPr>
-        <p:spPr>
-          <a:xfrm>
-            <a:off x="640080" y="4320540"/>
-            <a:ext cx="1280160" cy="54864"/>
-          </a:xfrm>
-          <a:prstGeom prst="rect">
-            <a:avLst/>
-          </a:prstGeom>
-          <a:solidFill>
-            <a:srgbClr val="D8542A"/>
-          </a:solidFill>
-          <a:ln>
-            <a:noFill/>
-          </a:ln>
-          <a:effectLst/>
-        </p:spPr>
-        <p:style>
-          <a:lnRef idx="1">
-            <a:schemeClr val="accent1"/>
-          </a:lnRef>
-          <a:fillRef idx="3">
-            <a:schemeClr val="accent1"/>
-          </a:fillRef>
-          <a:effectRef idx="2">
-            <a:schemeClr val="accent1"/>
-          </a:effectRef>
-          <a:fontRef idx="minor">
-            <a:schemeClr val="lt1"/>
-          </a:fontRef>
-        </p:style>
-        <p:txBody>
-          <a:bodyPr rtlCol="0" anchor="ctr"/>
-          <a:lstStyle/>
-          <a:p>
-            <a:pPr algn="ctr"/>
-          </a:p>
-        </p:txBody>
-      </p:sp>
-      <p:sp>
-        <p:nvSpPr>
-          <p:cNvPr id="5" name="TextBox 4"/>
+          <p:cNvPr id="4" name="TextBox 3"/>
           <p:cNvSpPr txBox="1"/>
           <p:nvPr/>
         </p:nvSpPr>
@@ -4235,7 +4191,7 @@
       </p:sp>
       <p:sp>
         <p:nvSpPr>
-          <p:cNvPr id="6" name="TextBox 5"/>
+          <p:cNvPr id="5" name="TextBox 4"/>
           <p:cNvSpPr txBox="1"/>
           <p:nvPr/>
         </p:nvSpPr>
@@ -4312,51 +4268,7 @@
       </p:sp>
       <p:sp>
         <p:nvSpPr>
-          <p:cNvPr id="7" name="Rectangle 6"/>
-          <p:cNvSpPr/>
-          <p:nvPr/>
-        </p:nvSpPr>
-        <p:spPr>
-          <a:xfrm>
-            <a:off x="658368" y="3310128"/>
-            <a:ext cx="1280160" cy="54864"/>
-          </a:xfrm>
-          <a:prstGeom prst="rect">
-            <a:avLst/>
-          </a:prstGeom>
-          <a:solidFill>
-            <a:srgbClr val="D8542A"/>
-          </a:solidFill>
-          <a:ln>
-            <a:noFill/>
-          </a:ln>
-          <a:effectLst/>
-        </p:spPr>
-        <p:style>
-          <a:lnRef idx="1">
-            <a:schemeClr val="accent1"/>
-          </a:lnRef>
-          <a:fillRef idx="3">
-            <a:schemeClr val="accent1"/>
-          </a:fillRef>
-          <a:effectRef idx="2">
-            <a:schemeClr val="accent1"/>
-          </a:effectRef>
-          <a:fontRef idx="minor">
-            <a:schemeClr val="lt1"/>
-          </a:fontRef>
-        </p:style>
-        <p:txBody>
-          <a:bodyPr rtlCol="0" anchor="ctr"/>
-          <a:lstStyle/>
-          <a:p>
-            <a:pPr algn="ctr"/>
-          </a:p>
-        </p:txBody>
-      </p:sp>
-      <p:sp>
-        <p:nvSpPr>
-          <p:cNvPr id="8" name="TextBox 7"/>
+          <p:cNvPr id="6" name="TextBox 5"/>
           <p:cNvSpPr txBox="1"/>
           <p:nvPr/>
         </p:nvSpPr>
@@ -4402,7 +4314,7 @@
       </p:sp>
       <p:sp>
         <p:nvSpPr>
-          <p:cNvPr id="9" name="TextBox 8"/>
+          <p:cNvPr id="7" name="TextBox 6"/>
           <p:cNvSpPr txBox="1"/>
           <p:nvPr/>
         </p:nvSpPr>

</xml_diff>